<commit_message>
Fix Project Overview slide: remove bullet glyph from intro prose
The opening paragraph rendered as a bulleted list item floating in
whitespace. Strip the inherited bullet (buNone), top-anchor the text,
enlarge to 20pt with 1.15 line spacing so the prose reads as a paragraph.

Co-Authored-By: Claude Opus 4.8 <noreply@anthropic.com>
Claude-Session: https://claude.ai/code/session_01JsNyv3VR42qJN6SBCK4mtP
</commit_message>
<xml_diff>
--- a/presentation/CoGen_CUP_Presentation.pptx
+++ b/presentation/CoGen_CUP_Presentation.pptx
@@ -16126,13 +16126,27 @@
             <p:ph idx="1"/>
           </p:nvPr>
         </p:nvSpPr>
-        <p:spPr/>
+        <p:spPr>
+          <a:xfrm>
+            <a:off x="0" y="1554480"/>
+            <a:ext cx="0" cy="4206240"/>
+          </a:xfrm>
+        </p:spPr>
         <p:txBody>
-          <a:bodyPr wrap="square"/>
+          <a:bodyPr wrap="square" anchor="t"/>
           <a:lstStyle/>
           <a:p>
-            <a:r>
-              <a:rPr sz="1800">
+            <a:pPr>
+              <a:lnSpc>
+                <a:spcPct val="115000"/>
+              </a:lnSpc>
+              <a:spcAft>
+                <a:spcPts val="1000"/>
+              </a:spcAft>
+              <a:buNone/>
+            </a:pPr>
+            <a:r>
+              <a:rPr sz="2000">
                 <a:solidFill>
                   <a:srgbClr val="292934"/>
                 </a:solidFill>

</xml_diff>